<commit_message>
Align the A0 poster with the fixed paper
- Both open cells and the Figure 1 caption now carry the future term in full,
  beta*phi*K*m/(m+m0), the same expression Table 1, Appendix A and the code use.
- The notation box defines it (beta discount, phi ecosystem efficiency, K external
  contributions, m compatibility share, m0 internal scale).
- The auction sentence no longer reads as winner-take-all: the highest E would take
  the prize, while our rule pays kE per open release, so the analogy covers who pays
  and not who is awarded (matches Section 3).
- The final-update milestone moves from September 30 to October 6.
- The results table shifts down 25 pt so the longer text keeps clear of it.
No change to any number, state or threshold.
</commit_message>
<xml_diff>
--- a/poster/PS2-FP04-CapabilityTransfer-A0-Poster.pptx
+++ b/poster/PS2-FP04-CapabilityTransfer-A0-Poster.pptx
@@ -2343,7 +2343,7 @@
                 </a:solidFill>
                 <a:latin typeface="Calibri"/>
               </a:rPr>
-              <a:t> = cost and compute of innovation · k = prize per unit of E · L = loss from disclosure · π = monopoly profit kept under secrecy.</a:t>
+              <a:t> = cost and compute of innovation · k = prize per unit of E · L = loss from disclosure · π = monopoly profit kept under secrecy · βφK·m/(m+m₀) = future share an open release buys (β discount · φ ecosystem efficiency · K external contributions · m compatibility share · m₀ internal scale).</a:t>
             </a:r>
           </a:p>
         </p:txBody>
@@ -2708,7 +2708,7 @@
                 </a:solidFill>
                 <a:latin typeface="Calibri"/>
               </a:rPr>
-              <a:t> (Baye et al. 1996): E is the bid, all bidders pay, the top E wins.</a:t>
+              <a:t> (Baye et al. 1996): E is the bid, all bidders pay, and the highest E would take the prize; our rule pays kE per open release, so the analogy covers who pays, not who is awarded.</a:t>
             </a:r>
           </a:p>
           <a:p xmlns:a="http://schemas.openxmlformats.org/drawingml/2006/main">
@@ -3249,7 +3249,7 @@
                 </a:solidFill>
                 <a:latin typeface="Calibri"/>
               </a:rPr>
-              <a:t> An open release also keeps the future market share it buys, βφK — the discounted value of the external contributions an open model attracts.</a:t>
+              <a:t> An open release also keeps the future market share it buys, βφK·m/(m+m₀) — the discounted value of the external contributions an open model attracts.</a:t>
             </a:r>
           </a:p>
         </p:txBody>
@@ -4564,7 +4564,7 @@
                 </a:solidFill>
                 <a:latin typeface="Calibri"/>
               </a:rPr>
-              <a:t>SEP 30  Final update</a:t>
+              <a:t>OCT 6  Final update</a:t>
             </a:r>
           </a:p>
         </p:txBody>
@@ -5927,7 +5927,7 @@
                 </a:solidFill>
                 <a:latin typeface="Calibri"/>
               </a:rPr>
-              <a:t> + βφK</a:t>
+              <a:t> + βφK·m/(m+m₀)</a:t>
             </a:r>
           </a:p>
         </p:txBody>
@@ -6239,7 +6239,7 @@
                 </a:solidFill>
                 <a:latin typeface="Calibri"/>
               </a:rPr>
-              <a:t> + βφK</a:t>
+              <a:t> + βφK·m/(m+m₀)</a:t>
             </a:r>
           </a:p>
         </p:txBody>
@@ -10185,7 +10185,7 @@
           <p:nvPr/>
         </p:nvGraphicFramePr>
         <p:xfrm xmlns:a="http://schemas.openxmlformats.org/drawingml/2006/main">
-          <a:off x="1333500" y="26555700"/>
+          <a:off x="1333500" y="26873200"/>
           <a:ext cx="11049000" cy="793750"/>
         </p:xfrm>
         <a:graphic xmlns:a="http://schemas.openxmlformats.org/drawingml/2006/main">

</xml_diff>

<commit_message>
Scope the private-order claim to a weak future-share motive, in paper and poster
The poster's Figure 2 stated that the private order holds while pi + L > Cn - Cd.
That condition only holds at beta*phi*K = 0: the run gives 100 percent of firms
choosing (1) with the motive off and 24.6 percent with it on, and the poster's own
panel (b) shows openness winning at k = 0. The caption now reads
'while pi + L - beta*phi*K > Cn - Cd, i.e. while the future-share motive is weak;
with a strong motive openness wins even at k = 0 (panel b).'

Section 2 states the same scope: 'At beta*phi*K = 0 the private ranking ...', so the
ranking and the motive paragraph read as one argument in both artifacts.
</commit_message>
<xml_diff>
--- a/poster/PS2-FP04-CapabilityTransfer-A0-Poster.pptx
+++ b/poster/PS2-FP04-CapabilityTransfer-A0-Poster.pptx
@@ -3421,7 +3421,7 @@
                 </a:solidFill>
                 <a:latin typeface="Calibri"/>
               </a:rPr>
-              <a:t>The private order (①&gt; ③&gt; ②&gt; ④) and the social order (④&gt; ②&gt; ③&gt; ①) are exact mirror images: the developer's favourite is society's least wanted. The private order holds while π + L &gt; C</a:t>
+              <a:t>The private order (①&gt; ③&gt; ②&gt; ④) and the social order (④&gt; ②&gt; ③&gt; ①) are exact mirror images: the developer's favourite is society's least wanted. The private order holds while π + L − βφK &gt; C</a:t>
             </a:r>
             <a:r>
               <a:rPr baseline="-25000" sz="2000" b="0">
@@ -3457,7 +3457,7 @@
                 </a:solidFill>
                 <a:latin typeface="Calibri"/>
               </a:rPr>
-              <a:t> — what secrecy keeps, plus what disclosure loses, must outweigh the extra cost of innovating.</a:t>
+              <a:t>, i.e. while the future-share motive is weak; with a strong motive openness wins even at k = 0 (panel b).</a:t>
             </a:r>
           </a:p>
           <a:p xmlns:a="http://schemas.openxmlformats.org/drawingml/2006/main">

</xml_diff>

<commit_message>
Three poster corrections: model statement, conflict labels, unit claim
- 'Players one developer chooses...' becomes 'Players N firms each choose...', and the
  limitation reads 'static and one-shot, with no reaction between firms' instead of
  'single-firm and static', so the poster states the same model as the paper.
- Figure 2 labels the cells by rank gap: (1) and (4) keep 'Largest conflict', and (2)
  and (3) both read 'Small conflict' (each is one rank apart), instead of one reading
  'Eased' and the other 'Conflict'.
- The footer no longer claims that training compute E is measured in FLOP: the run's E
  is in abstract units and the paper never states a unit.
</commit_message>
<xml_diff>
--- a/poster/PS2-FP04-CapabilityTransfer-A0-Poster.pptx
+++ b/poster/PS2-FP04-CapabilityTransfer-A0-Poster.pptx
@@ -2115,7 +2115,7 @@
                 </a:solidFill>
                 <a:latin typeface="Calibri"/>
               </a:rPr>
-              <a:t>one developer chooses sourcing (imitate or innovate) and release (secrecy or openness).</a:t>
+              <a:t>N firms each choose sourcing (imitate or innovate) and release (secrecy or openness).</a:t>
             </a:r>
           </a:p>
           <a:p xmlns:a="http://schemas.openxmlformats.org/drawingml/2006/main">
@@ -4399,7 +4399,7 @@
                 </a:solidFill>
                 <a:latin typeface="Calibri"/>
               </a:rPr>
-              <a:t>single-firm and static: it shows where the market settles, not how fast.</a:t>
+              <a:t>static and one-shot, with no reaction between firms: it shows where the market settles, not how fast.</a:t>
             </a:r>
           </a:p>
           <a:p xmlns:a="http://schemas.openxmlformats.org/drawingml/2006/main">
@@ -5283,7 +5283,7 @@
                 </a:solidFill>
                 <a:latin typeface="Calibri"/>
               </a:rPr>
-              <a:t>A0 landscape · editable PPTX + PDF · training compute E is measured in FLOP.</a:t>
+              <a:t>A0 landscape · editable PPTX + PDF.</a:t>
             </a:r>
           </a:p>
         </p:txBody>
@@ -7735,7 +7735,7 @@
                 </a:solidFill>
                 <a:latin typeface="Calibri"/>
               </a:rPr>
-              <a:t>←  Conflict</a:t>
+              <a:t>←  Small conflict</a:t>
             </a:r>
           </a:p>
         </p:txBody>
@@ -8353,7 +8353,7 @@
                 </a:solidFill>
                 <a:latin typeface="Calibri"/>
               </a:rPr>
-              <a:t>←  Eased</a:t>
+              <a:t>←  Small conflict</a:t>
             </a:r>
           </a:p>
         </p:txBody>

</xml_diff>